<commit_message>
Fixed last bits of documentation
</commit_message>
<xml_diff>
--- a/Documentation/Milestone Documentation/Milestone 4/BIN381 Project Final Presentation Submit.pptx
+++ b/Documentation/Milestone Documentation/Milestone 4/BIN381 Project Final Presentation Submit.pptx
@@ -1960,7 +1960,7 @@
           </a:prstGeom>
           <a:extLst>
             <a:ext uri="{C572A759-6A51-4108-AA02-DFA0A04FC94B}">
-              <ma14:wrappingTextBoxFlag xmlns:ma14="http://schemas.microsoft.com/office/mac/drawingml/2011/main" xmlns="" val="0"/>
+              <ma14:wrappingTextBoxFlag xmlns="" xmlns:ma14="http://schemas.microsoft.com/office/mac/drawingml/2011/main" val="0"/>
             </a:ext>
           </a:extLst>
         </p:spPr>
@@ -4392,7 +4392,7 @@
           </a:prstGeom>
           <a:extLst>
             <a:ext uri="{C572A759-6A51-4108-AA02-DFA0A04FC94B}">
-              <ma14:wrappingTextBoxFlag xmlns:ma14="http://schemas.microsoft.com/office/mac/drawingml/2011/main" xmlns="" val="0"/>
+              <ma14:wrappingTextBoxFlag xmlns="" xmlns:ma14="http://schemas.microsoft.com/office/mac/drawingml/2011/main" val="0"/>
             </a:ext>
           </a:extLst>
         </p:spPr>
@@ -4579,7 +4579,7 @@
           </a:prstGeom>
           <a:extLst>
             <a:ext uri="{C572A759-6A51-4108-AA02-DFA0A04FC94B}">
-              <ma14:wrappingTextBoxFlag xmlns:ma14="http://schemas.microsoft.com/office/mac/drawingml/2011/main" xmlns="" val="0"/>
+              <ma14:wrappingTextBoxFlag xmlns="" xmlns:ma14="http://schemas.microsoft.com/office/mac/drawingml/2011/main" val="0"/>
             </a:ext>
           </a:extLst>
         </p:spPr>
@@ -4961,7 +4961,7 @@
           </a:prstGeom>
           <a:extLst>
             <a:ext uri="{C572A759-6A51-4108-AA02-DFA0A04FC94B}">
-              <ma14:wrappingTextBoxFlag xmlns:ma14="http://schemas.microsoft.com/office/mac/drawingml/2011/main" xmlns="" val="0"/>
+              <ma14:wrappingTextBoxFlag xmlns="" xmlns:ma14="http://schemas.microsoft.com/office/mac/drawingml/2011/main" val="0"/>
             </a:ext>
           </a:extLst>
         </p:spPr>
@@ -5264,7 +5264,7 @@
           </a:prstGeom>
           <a:extLst>
             <a:ext uri="{C572A759-6A51-4108-AA02-DFA0A04FC94B}">
-              <ma14:wrappingTextBoxFlag xmlns:ma14="http://schemas.microsoft.com/office/mac/drawingml/2011/main" xmlns="" val="0"/>
+              <ma14:wrappingTextBoxFlag xmlns="" xmlns:ma14="http://schemas.microsoft.com/office/mac/drawingml/2011/main" val="0"/>
             </a:ext>
           </a:extLst>
         </p:spPr>
@@ -5492,7 +5492,7 @@
           </a:prstGeom>
           <a:extLst>
             <a:ext uri="{C572A759-6A51-4108-AA02-DFA0A04FC94B}">
-              <ma14:wrappingTextBoxFlag xmlns:ma14="http://schemas.microsoft.com/office/mac/drawingml/2011/main" xmlns="" val="0"/>
+              <ma14:wrappingTextBoxFlag xmlns="" xmlns:ma14="http://schemas.microsoft.com/office/mac/drawingml/2011/main" val="0"/>
             </a:ext>
           </a:extLst>
         </p:spPr>
@@ -5801,7 +5801,7 @@
           </a:prstGeom>
           <a:extLst>
             <a:ext uri="{C572A759-6A51-4108-AA02-DFA0A04FC94B}">
-              <ma14:wrappingTextBoxFlag xmlns:ma14="http://schemas.microsoft.com/office/mac/drawingml/2011/main" xmlns="" val="0"/>
+              <ma14:wrappingTextBoxFlag xmlns="" xmlns:ma14="http://schemas.microsoft.com/office/mac/drawingml/2011/main" val="0"/>
             </a:ext>
           </a:extLst>
         </p:spPr>
@@ -5877,7 +5877,7 @@
           </a:prstGeom>
           <a:extLst>
             <a:ext uri="{C572A759-6A51-4108-AA02-DFA0A04FC94B}">
-              <ma14:wrappingTextBoxFlag xmlns:ma14="http://schemas.microsoft.com/office/mac/drawingml/2011/main" xmlns="" val="0"/>
+              <ma14:wrappingTextBoxFlag xmlns="" xmlns:ma14="http://schemas.microsoft.com/office/mac/drawingml/2011/main" val="0"/>
             </a:ext>
           </a:extLst>
         </p:spPr>
@@ -6447,7 +6447,7 @@
           </a:prstGeom>
           <a:extLst>
             <a:ext uri="{C572A759-6A51-4108-AA02-DFA0A04FC94B}">
-              <ma14:wrappingTextBoxFlag xmlns:ma14="http://schemas.microsoft.com/office/mac/drawingml/2011/main" xmlns="" val="0"/>
+              <ma14:wrappingTextBoxFlag xmlns="" xmlns:ma14="http://schemas.microsoft.com/office/mac/drawingml/2011/main" val="0"/>
             </a:ext>
           </a:extLst>
         </p:spPr>
@@ -6662,7 +6662,7 @@
                 </a:solidFill>
                 <a:latin typeface="Century" panose="02040604050505020304" pitchFamily="18" charset="0"/>
               </a:rPr>
-              <a:t>With matric, home internet goes with 6.3 more people employed per 10 and without matric</a:t>
+              <a:t>With matric, home internet goes with 6.3 more people employed per 100 and without matric</a:t>
             </a:r>
             <a:r>
               <a:rPr lang="en-ZA" sz="1400" dirty="0">
@@ -7165,41 +7165,8 @@
                 </a:solidFill>
                 <a:latin typeface="Century" panose="02040604050505020304" pitchFamily="18" charset="0"/>
               </a:rPr>
-              <a:t>A</a:t>
-            </a:r>
-            <a:r>
-              <a:rPr lang="en-ZA" sz="1300" b="0" noProof="0" dirty="0" err="1">
-                <a:solidFill>
-                  <a:schemeClr val="bg1"/>
-                </a:solidFill>
-                <a:latin typeface="Century" panose="02040604050505020304" pitchFamily="18" charset="0"/>
-              </a:rPr>
-              <a:t>ccuracy</a:t>
-            </a:r>
-            <a:r>
-              <a:rPr lang="en-ZA" sz="1300" b="0" noProof="0" dirty="0">
-                <a:solidFill>
-                  <a:schemeClr val="bg1"/>
-                </a:solidFill>
-                <a:latin typeface="Century" panose="02040604050505020304" pitchFamily="18" charset="0"/>
-              </a:rPr>
-              <a:t> differs across population groups</a:t>
-            </a:r>
-            <a:r>
-              <a:rPr lang="en-ZA" sz="1300" dirty="0">
-                <a:solidFill>
-                  <a:schemeClr val="bg1"/>
-                </a:solidFill>
-                <a:latin typeface="Century" panose="02040604050505020304" pitchFamily="18" charset="0"/>
-              </a:rPr>
-              <a:t> and not across individuals (Race groups need to be created, otherwise the data is skewed due to the 71% black unemployment number).</a:t>
-            </a:r>
-            <a:endParaRPr lang="en-ZA" sz="1300" b="0" noProof="0" dirty="0">
-              <a:solidFill>
-                <a:schemeClr val="bg1"/>
-              </a:solidFill>
-              <a:latin typeface="Century" panose="02040604050505020304" pitchFamily="18" charset="0"/>
-            </a:endParaRPr>
+              <a:t>Accuracy differs across groups, with the model spotting 71% of unemployed Black African respondents but only 4% of unemployed White respondents, so it is for groups only.</a:t>
+            </a:r>
           </a:p>
           <a:p>
             <a:pPr marL="228600" indent="-228600">
@@ -7354,7 +7321,7 @@
           </a:prstGeom>
           <a:extLst>
             <a:ext uri="{C572A759-6A51-4108-AA02-DFA0A04FC94B}">
-              <ma14:wrappingTextBoxFlag xmlns="" xmlns:ma14="http://schemas.microsoft.com/office/mac/drawingml/2011/main" val="0"/>
+              <ma14:wrappingTextBoxFlag xmlns:ma14="http://schemas.microsoft.com/office/mac/drawingml/2011/main" xmlns="" val="0"/>
             </a:ext>
           </a:extLst>
         </p:spPr>
@@ -7754,7 +7721,7 @@
           </a:prstGeom>
           <a:extLst>
             <a:ext uri="{C572A759-6A51-4108-AA02-DFA0A04FC94B}">
-              <ma14:wrappingTextBoxFlag xmlns:ma14="http://schemas.microsoft.com/office/mac/drawingml/2011/main" xmlns="" val="0"/>
+              <ma14:wrappingTextBoxFlag xmlns="" xmlns:ma14="http://schemas.microsoft.com/office/mac/drawingml/2011/main" val="0"/>
             </a:ext>
           </a:extLst>
         </p:spPr>
@@ -8354,7 +8321,7 @@
                 </a:solidFill>
                 <a:latin typeface="Century" panose="02040604050505020304" pitchFamily="18" charset="0"/>
               </a:rPr>
-              <a:t>boost each other, replace each other or have no effect together with regards to education</a:t>
+              <a:t>boost each other, replace each other or have no effect together with regards to employment</a:t>
             </a:r>
             <a:r>
               <a:rPr lang="en-ZA" sz="1400" b="0" noProof="0" dirty="0">
@@ -8456,7 +8423,7 @@
           </a:prstGeom>
           <a:extLst>
             <a:ext uri="{C572A759-6A51-4108-AA02-DFA0A04FC94B}">
-              <ma14:wrappingTextBoxFlag xmlns:ma14="http://schemas.microsoft.com/office/mac/drawingml/2011/main" xmlns="" val="0"/>
+              <ma14:wrappingTextBoxFlag xmlns="" xmlns:ma14="http://schemas.microsoft.com/office/mac/drawingml/2011/main" val="0"/>
             </a:ext>
           </a:extLst>
         </p:spPr>
@@ -9703,7 +9670,7 @@
               <a:rPr lang="en-ZA" sz="1300" dirty="0">
                 <a:latin typeface="Century" panose="02040604050505020304" pitchFamily="18" charset="0"/>
               </a:rPr>
-              <a:t>, meaning instead of 20000 distinct households there was only 1 with the value: 1.60e17.</a:t>
+              <a:t>, meaning instead of 20940 distinct households there was only 20684 with the value: 1.60e17.</a:t>
             </a:r>
             <a:endParaRPr lang="en-ZA" sz="1300" b="0" noProof="0" dirty="0">
               <a:solidFill>
@@ -9852,7 +9819,7 @@
                 </a:solidFill>
                 <a:latin typeface="Century" panose="02040604050505020304" pitchFamily="18" charset="0"/>
               </a:rPr>
-              <a:t>not applicable” and “non-response”, meaning that 74% (94% after cleaning) of </a:t>
+              <a:t>not applicable” and “non-response”, meaning that 74% of </a:t>
             </a:r>
             <a:r>
               <a:rPr lang="en-ZA" sz="1300" dirty="0">
@@ -10102,7 +10069,7 @@
           </a:prstGeom>
           <a:extLst>
             <a:ext uri="{C572A759-6A51-4108-AA02-DFA0A04FC94B}">
-              <ma14:wrappingTextBoxFlag xmlns:ma14="http://schemas.microsoft.com/office/mac/drawingml/2011/main" xmlns="" val="0"/>
+              <ma14:wrappingTextBoxFlag xmlns="" xmlns:ma14="http://schemas.microsoft.com/office/mac/drawingml/2011/main" val="0"/>
             </a:ext>
           </a:extLst>
         </p:spPr>
@@ -10650,7 +10617,7 @@
               <a:rPr lang="en-ZA" sz="1400" dirty="0">
                 <a:latin typeface="Century" panose="02040604050505020304" pitchFamily="18" charset="0"/>
               </a:rPr>
-              <a:t>Scaling the data, Encoding it and grouping our data into, for example age groups. </a:t>
+              <a:t>Encoding the data, and grouping our data into, for example age groups. </a:t>
             </a:r>
             <a:endParaRPr lang="en-ZA" sz="1400" b="0" noProof="0" dirty="0">
               <a:solidFill>
@@ -11565,7 +11532,7 @@
           </a:prstGeom>
           <a:extLst>
             <a:ext uri="{C572A759-6A51-4108-AA02-DFA0A04FC94B}">
-              <ma14:wrappingTextBoxFlag xmlns:ma14="http://schemas.microsoft.com/office/mac/drawingml/2011/main" xmlns="" val="0"/>
+              <ma14:wrappingTextBoxFlag xmlns="" xmlns:ma14="http://schemas.microsoft.com/office/mac/drawingml/2011/main" val="0"/>
             </a:ext>
           </a:extLst>
         </p:spPr>
@@ -12631,7 +12598,7 @@
                 </a:solidFill>
                 <a:latin typeface="Century" panose="02040604050505020304" pitchFamily="18" charset="0"/>
               </a:rPr>
-              <a:t> (No salary for 96% of people)</a:t>
+              <a:t> (No salary for 74% of people)</a:t>
             </a:r>
             <a:endParaRPr lang="en-ZA" sz="1400" b="0" noProof="0" dirty="0">
               <a:solidFill>
@@ -12742,7 +12709,7 @@
           </a:prstGeom>
           <a:extLst>
             <a:ext uri="{C572A759-6A51-4108-AA02-DFA0A04FC94B}">
-              <ma14:wrappingTextBoxFlag xmlns:ma14="http://schemas.microsoft.com/office/mac/drawingml/2011/main" xmlns="" val="0"/>
+              <ma14:wrappingTextBoxFlag xmlns="" xmlns:ma14="http://schemas.microsoft.com/office/mac/drawingml/2011/main" val="0"/>
             </a:ext>
           </a:extLst>
         </p:spPr>
@@ -13512,7 +13479,7 @@
           </a:prstGeom>
           <a:extLst>
             <a:ext uri="{C572A759-6A51-4108-AA02-DFA0A04FC94B}">
-              <ma14:wrappingTextBoxFlag xmlns:ma14="http://schemas.microsoft.com/office/mac/drawingml/2011/main" xmlns="" val="0"/>
+              <ma14:wrappingTextBoxFlag xmlns="" xmlns:ma14="http://schemas.microsoft.com/office/mac/drawingml/2011/main" val="0"/>
             </a:ext>
           </a:extLst>
         </p:spPr>
@@ -14164,7 +14131,7 @@
           </a:prstGeom>
           <a:extLst>
             <a:ext uri="{C572A759-6A51-4108-AA02-DFA0A04FC94B}">
-              <ma14:wrappingTextBoxFlag xmlns:ma14="http://schemas.microsoft.com/office/mac/drawingml/2011/main" xmlns="" val="0"/>
+              <ma14:wrappingTextBoxFlag xmlns="" xmlns:ma14="http://schemas.microsoft.com/office/mac/drawingml/2011/main" val="0"/>
             </a:ext>
           </a:extLst>
         </p:spPr>

</xml_diff>

<commit_message>
Final touch ups on documents
</commit_message>
<xml_diff>
--- a/Documentation/Milestone Documentation/Milestone 4/BIN381 Project Final Presentation Submit.pptx
+++ b/Documentation/Milestone Documentation/Milestone 4/BIN381 Project Final Presentation Submit.pptx
@@ -1960,7 +1960,7 @@
           </a:prstGeom>
           <a:extLst>
             <a:ext uri="{C572A759-6A51-4108-AA02-DFA0A04FC94B}">
-              <ma14:wrappingTextBoxFlag xmlns="" xmlns:ma14="http://schemas.microsoft.com/office/mac/drawingml/2011/main" val="0"/>
+              <ma14:wrappingTextBoxFlag xmlns:ma14="http://schemas.microsoft.com/office/mac/drawingml/2011/main" xmlns="" val="0"/>
             </a:ext>
           </a:extLst>
         </p:spPr>
@@ -4392,7 +4392,7 @@
           </a:prstGeom>
           <a:extLst>
             <a:ext uri="{C572A759-6A51-4108-AA02-DFA0A04FC94B}">
-              <ma14:wrappingTextBoxFlag xmlns="" xmlns:ma14="http://schemas.microsoft.com/office/mac/drawingml/2011/main" val="0"/>
+              <ma14:wrappingTextBoxFlag xmlns:ma14="http://schemas.microsoft.com/office/mac/drawingml/2011/main" xmlns="" val="0"/>
             </a:ext>
           </a:extLst>
         </p:spPr>
@@ -4579,7 +4579,7 @@
           </a:prstGeom>
           <a:extLst>
             <a:ext uri="{C572A759-6A51-4108-AA02-DFA0A04FC94B}">
-              <ma14:wrappingTextBoxFlag xmlns="" xmlns:ma14="http://schemas.microsoft.com/office/mac/drawingml/2011/main" val="0"/>
+              <ma14:wrappingTextBoxFlag xmlns:ma14="http://schemas.microsoft.com/office/mac/drawingml/2011/main" xmlns="" val="0"/>
             </a:ext>
           </a:extLst>
         </p:spPr>
@@ -4961,7 +4961,7 @@
           </a:prstGeom>
           <a:extLst>
             <a:ext uri="{C572A759-6A51-4108-AA02-DFA0A04FC94B}">
-              <ma14:wrappingTextBoxFlag xmlns="" xmlns:ma14="http://schemas.microsoft.com/office/mac/drawingml/2011/main" val="0"/>
+              <ma14:wrappingTextBoxFlag xmlns:ma14="http://schemas.microsoft.com/office/mac/drawingml/2011/main" xmlns="" val="0"/>
             </a:ext>
           </a:extLst>
         </p:spPr>
@@ -5264,7 +5264,7 @@
           </a:prstGeom>
           <a:extLst>
             <a:ext uri="{C572A759-6A51-4108-AA02-DFA0A04FC94B}">
-              <ma14:wrappingTextBoxFlag xmlns="" xmlns:ma14="http://schemas.microsoft.com/office/mac/drawingml/2011/main" val="0"/>
+              <ma14:wrappingTextBoxFlag xmlns:ma14="http://schemas.microsoft.com/office/mac/drawingml/2011/main" xmlns="" val="0"/>
             </a:ext>
           </a:extLst>
         </p:spPr>
@@ -5492,7 +5492,7 @@
           </a:prstGeom>
           <a:extLst>
             <a:ext uri="{C572A759-6A51-4108-AA02-DFA0A04FC94B}">
-              <ma14:wrappingTextBoxFlag xmlns="" xmlns:ma14="http://schemas.microsoft.com/office/mac/drawingml/2011/main" val="0"/>
+              <ma14:wrappingTextBoxFlag xmlns:ma14="http://schemas.microsoft.com/office/mac/drawingml/2011/main" xmlns="" val="0"/>
             </a:ext>
           </a:extLst>
         </p:spPr>
@@ -5801,7 +5801,7 @@
           </a:prstGeom>
           <a:extLst>
             <a:ext uri="{C572A759-6A51-4108-AA02-DFA0A04FC94B}">
-              <ma14:wrappingTextBoxFlag xmlns="" xmlns:ma14="http://schemas.microsoft.com/office/mac/drawingml/2011/main" val="0"/>
+              <ma14:wrappingTextBoxFlag xmlns:ma14="http://schemas.microsoft.com/office/mac/drawingml/2011/main" xmlns="" val="0"/>
             </a:ext>
           </a:extLst>
         </p:spPr>
@@ -5877,7 +5877,7 @@
           </a:prstGeom>
           <a:extLst>
             <a:ext uri="{C572A759-6A51-4108-AA02-DFA0A04FC94B}">
-              <ma14:wrappingTextBoxFlag xmlns="" xmlns:ma14="http://schemas.microsoft.com/office/mac/drawingml/2011/main" val="0"/>
+              <ma14:wrappingTextBoxFlag xmlns:ma14="http://schemas.microsoft.com/office/mac/drawingml/2011/main" xmlns="" val="0"/>
             </a:ext>
           </a:extLst>
         </p:spPr>
@@ -6447,7 +6447,7 @@
           </a:prstGeom>
           <a:extLst>
             <a:ext uri="{C572A759-6A51-4108-AA02-DFA0A04FC94B}">
-              <ma14:wrappingTextBoxFlag xmlns="" xmlns:ma14="http://schemas.microsoft.com/office/mac/drawingml/2011/main" val="0"/>
+              <ma14:wrappingTextBoxFlag xmlns:ma14="http://schemas.microsoft.com/office/mac/drawingml/2011/main" xmlns="" val="0"/>
             </a:ext>
           </a:extLst>
         </p:spPr>
@@ -7321,7 +7321,7 @@
           </a:prstGeom>
           <a:extLst>
             <a:ext uri="{C572A759-6A51-4108-AA02-DFA0A04FC94B}">
-              <ma14:wrappingTextBoxFlag xmlns:ma14="http://schemas.microsoft.com/office/mac/drawingml/2011/main" xmlns="" val="0"/>
+              <ma14:wrappingTextBoxFlag xmlns="" xmlns:ma14="http://schemas.microsoft.com/office/mac/drawingml/2011/main" val="0"/>
             </a:ext>
           </a:extLst>
         </p:spPr>
@@ -7721,7 +7721,7 @@
           </a:prstGeom>
           <a:extLst>
             <a:ext uri="{C572A759-6A51-4108-AA02-DFA0A04FC94B}">
-              <ma14:wrappingTextBoxFlag xmlns="" xmlns:ma14="http://schemas.microsoft.com/office/mac/drawingml/2011/main" val="0"/>
+              <ma14:wrappingTextBoxFlag xmlns:ma14="http://schemas.microsoft.com/office/mac/drawingml/2011/main" xmlns="" val="0"/>
             </a:ext>
           </a:extLst>
         </p:spPr>
@@ -8423,7 +8423,7 @@
           </a:prstGeom>
           <a:extLst>
             <a:ext uri="{C572A759-6A51-4108-AA02-DFA0A04FC94B}">
-              <ma14:wrappingTextBoxFlag xmlns="" xmlns:ma14="http://schemas.microsoft.com/office/mac/drawingml/2011/main" val="0"/>
+              <ma14:wrappingTextBoxFlag xmlns:ma14="http://schemas.microsoft.com/office/mac/drawingml/2011/main" xmlns="" val="0"/>
             </a:ext>
           </a:extLst>
         </p:spPr>
@@ -9670,7 +9670,13 @@
               <a:rPr lang="en-ZA" sz="1300" dirty="0">
                 <a:latin typeface="Century" panose="02040604050505020304" pitchFamily="18" charset="0"/>
               </a:rPr>
-              <a:t>, meaning instead of 20940 distinct households there was only 20684 with the value: 1.60e17.</a:t>
+              <a:t>, meaning instead of 20940 distinct households there was </a:t>
+            </a:r>
+            <a:r>
+              <a:rPr lang="en-ZA" sz="1300">
+                <a:latin typeface="Century" panose="02040604050505020304" pitchFamily="18" charset="0"/>
+              </a:rPr>
+              <a:t>only 20684.</a:t>
             </a:r>
             <a:endParaRPr lang="en-ZA" sz="1300" b="0" noProof="0" dirty="0">
               <a:solidFill>
@@ -9825,7 +9831,7 @@
               <a:rPr lang="en-ZA" sz="1300" dirty="0">
                 <a:latin typeface="Century" panose="02040604050505020304" pitchFamily="18" charset="0"/>
               </a:rPr>
-              <a:t>the sample </a:t>
+              <a:t>the sample do not have a job or </a:t>
             </a:r>
             <a:r>
               <a:rPr lang="en-ZA" sz="1300" b="0" noProof="0" dirty="0">
@@ -9834,7 +9840,7 @@
                 </a:solidFill>
                 <a:latin typeface="Century" panose="02040604050505020304" pitchFamily="18" charset="0"/>
               </a:rPr>
-              <a:t>didn’t get paid or didn’t want to reveal their salary.</a:t>
+              <a:t>didn’t want to reveal their salary.</a:t>
             </a:r>
           </a:p>
         </p:txBody>
@@ -10069,7 +10075,7 @@
           </a:prstGeom>
           <a:extLst>
             <a:ext uri="{C572A759-6A51-4108-AA02-DFA0A04FC94B}">
-              <ma14:wrappingTextBoxFlag xmlns="" xmlns:ma14="http://schemas.microsoft.com/office/mac/drawingml/2011/main" val="0"/>
+              <ma14:wrappingTextBoxFlag xmlns:ma14="http://schemas.microsoft.com/office/mac/drawingml/2011/main" xmlns="" val="0"/>
             </a:ext>
           </a:extLst>
         </p:spPr>
@@ -11532,7 +11538,7 @@
           </a:prstGeom>
           <a:extLst>
             <a:ext uri="{C572A759-6A51-4108-AA02-DFA0A04FC94B}">
-              <ma14:wrappingTextBoxFlag xmlns="" xmlns:ma14="http://schemas.microsoft.com/office/mac/drawingml/2011/main" val="0"/>
+              <ma14:wrappingTextBoxFlag xmlns:ma14="http://schemas.microsoft.com/office/mac/drawingml/2011/main" xmlns="" val="0"/>
             </a:ext>
           </a:extLst>
         </p:spPr>
@@ -12709,7 +12715,7 @@
           </a:prstGeom>
           <a:extLst>
             <a:ext uri="{C572A759-6A51-4108-AA02-DFA0A04FC94B}">
-              <ma14:wrappingTextBoxFlag xmlns="" xmlns:ma14="http://schemas.microsoft.com/office/mac/drawingml/2011/main" val="0"/>
+              <ma14:wrappingTextBoxFlag xmlns:ma14="http://schemas.microsoft.com/office/mac/drawingml/2011/main" xmlns="" val="0"/>
             </a:ext>
           </a:extLst>
         </p:spPr>
@@ -13479,7 +13485,7 @@
           </a:prstGeom>
           <a:extLst>
             <a:ext uri="{C572A759-6A51-4108-AA02-DFA0A04FC94B}">
-              <ma14:wrappingTextBoxFlag xmlns="" xmlns:ma14="http://schemas.microsoft.com/office/mac/drawingml/2011/main" val="0"/>
+              <ma14:wrappingTextBoxFlag xmlns:ma14="http://schemas.microsoft.com/office/mac/drawingml/2011/main" xmlns="" val="0"/>
             </a:ext>
           </a:extLst>
         </p:spPr>
@@ -14131,7 +14137,7 @@
           </a:prstGeom>
           <a:extLst>
             <a:ext uri="{C572A759-6A51-4108-AA02-DFA0A04FC94B}">
-              <ma14:wrappingTextBoxFlag xmlns="" xmlns:ma14="http://schemas.microsoft.com/office/mac/drawingml/2011/main" val="0"/>
+              <ma14:wrappingTextBoxFlag xmlns:ma14="http://schemas.microsoft.com/office/mac/drawingml/2011/main" xmlns="" val="0"/>
             </a:ext>
           </a:extLst>
         </p:spPr>

</xml_diff>